<commit_message>
Remove narrativa de mudança de preço e adiciona projeção de mercado
Tira as menções de "atualizado de R\$2.500 para R\$3.500" dos 5 pilares,
resumo do business plan e CLAUDE.md — R\$3.500 passa a ser simplesmente o
preço, sem histórico. Recalcula comparativos de custo que ainda usavam
R\$2.500 como preço do OCEO. Adiciona slide de meta de mercado no
PowerPoint: 0,1% de 24 milhões de PMEs = 24.000 clientes x R\$3.500 x 12
meses = R\$1,008 bi de receita anual projetada (marcado como meta, não fato).
</commit_message>
<xml_diff>
--- a/outros-projetos/oceo/OCEO - Business Plan (5 Pilares).pptx
+++ b/outros-projetos/oceo/OCEO - Business Plan (5 Pilares).pptx
@@ -20,6 +20,7 @@
     <p:sldId id="268" r:id="rId19"/>
     <p:sldId id="269" r:id="rId20"/>
     <p:sldId id="270" r:id="rId21"/>
+    <p:sldId id="271" r:id="rId22"/>
   </p:sldIdLst>
   <p:sldSz cx="12191695" cy="6858000" type="screen4x3"/>
   <p:notesSz cx="6858000" cy="9144000"/>
@@ -7736,6 +7737,1084 @@
     <p:bg>
       <p:bgPr>
         <a:solidFill>
+          <a:srgbClr val="0B1220"/>
+        </a:solidFill>
+        <a:effectLst/>
+      </p:bgPr>
+    </p:bg>
+    <p:spTree>
+      <p:nvGrpSpPr>
+        <p:cNvPr id="1" name=""/>
+        <p:cNvGrpSpPr/>
+        <p:nvPr/>
+      </p:nvGrpSpPr>
+      <p:grpSpPr/>
+      <p:cxnSp>
+        <p:nvCxnSpPr>
+          <p:cNvPr id="2" name="Connector 1"/>
+          <p:cNvCxnSpPr/>
+          <p:nvPr/>
+        </p:nvCxnSpPr>
+        <p:spPr>
+          <a:xfrm>
+            <a:off x="640080" y="591820"/>
+            <a:ext cx="256032" cy="0"/>
+          </a:xfrm>
+          <a:prstGeom prst="line">
+            <a:avLst/>
+          </a:prstGeom>
+          <a:ln w="19050">
+            <a:solidFill>
+              <a:srgbClr val="6FA8F0"/>
+            </a:solidFill>
+          </a:ln>
+        </p:spPr>
+        <p:style>
+          <a:lnRef idx="2">
+            <a:schemeClr val="accent1"/>
+          </a:lnRef>
+          <a:fillRef idx="0">
+            <a:schemeClr val="accent1"/>
+          </a:fillRef>
+          <a:effectRef idx="1">
+            <a:schemeClr val="accent1"/>
+          </a:effectRef>
+          <a:fontRef idx="minor">
+            <a:schemeClr val="tx1"/>
+          </a:fontRef>
+        </p:style>
+      </p:cxnSp>
+      <p:sp>
+        <p:nvSpPr>
+          <p:cNvPr id="3" name="TextBox 2"/>
+          <p:cNvSpPr txBox="1"/>
+          <p:nvPr/>
+        </p:nvSpPr>
+        <p:spPr>
+          <a:xfrm>
+            <a:off x="969264" y="502920"/>
+            <a:ext cx="5486400" cy="274320"/>
+          </a:xfrm>
+          <a:prstGeom prst="rect">
+            <a:avLst/>
+          </a:prstGeom>
+          <a:noFill/>
+        </p:spPr>
+        <p:txBody>
+          <a:bodyPr wrap="square" anchor="t" lIns="0" rIns="0" tIns="0" bIns="0">
+            <a:spAutoFit/>
+          </a:bodyPr>
+          <a:lstStyle/>
+          <a:p>
+            <a:pPr algn="l">
+              <a:lnSpc>
+                <a:spcPct val="100000"/>
+              </a:lnSpc>
+            </a:pPr>
+            <a:r>
+              <a:rPr sz="1100" b="1" i="0">
+                <a:solidFill>
+                  <a:srgbClr val="6FA8F0"/>
+                </a:solidFill>
+                <a:latin typeface="Arial"/>
+              </a:rPr>
+              <a:t>05 · META DE MERCADO</a:t>
+            </a:r>
+          </a:p>
+        </p:txBody>
+      </p:sp>
+      <p:sp>
+        <p:nvSpPr>
+          <p:cNvPr id="4" name="TextBox 3"/>
+          <p:cNvSpPr txBox="1"/>
+          <p:nvPr/>
+        </p:nvSpPr>
+        <p:spPr>
+          <a:xfrm>
+            <a:off x="621792" y="841248"/>
+            <a:ext cx="10515600" cy="731520"/>
+          </a:xfrm>
+          <a:prstGeom prst="rect">
+            <a:avLst/>
+          </a:prstGeom>
+          <a:noFill/>
+        </p:spPr>
+        <p:txBody>
+          <a:bodyPr wrap="square" anchor="t" lIns="0" rIns="0" tIns="0" bIns="0">
+            <a:spAutoFit/>
+          </a:bodyPr>
+          <a:lstStyle/>
+          <a:p>
+            <a:pPr algn="l">
+              <a:lnSpc>
+                <a:spcPct val="100000"/>
+              </a:lnSpc>
+            </a:pPr>
+            <a:r>
+              <a:rPr sz="2700" b="1" i="0">
+                <a:solidFill>
+                  <a:srgbClr val="FFFFFF"/>
+                </a:solidFill>
+                <a:latin typeface="Arial"/>
+              </a:rPr>
+              <a:t>Se o OCEO capturar 0,1% desse mercado</a:t>
+            </a:r>
+          </a:p>
+        </p:txBody>
+      </p:sp>
+      <p:cxnSp>
+        <p:nvCxnSpPr>
+          <p:cNvPr id="5" name="Connector 4"/>
+          <p:cNvCxnSpPr/>
+          <p:nvPr/>
+        </p:nvCxnSpPr>
+        <p:spPr>
+          <a:xfrm>
+            <a:off x="640080" y="1417320"/>
+            <a:ext cx="457200" cy="0"/>
+          </a:xfrm>
+          <a:prstGeom prst="line">
+            <a:avLst/>
+          </a:prstGeom>
+          <a:ln w="28575">
+            <a:solidFill>
+              <a:srgbClr val="DD9A34"/>
+            </a:solidFill>
+          </a:ln>
+        </p:spPr>
+        <p:style>
+          <a:lnRef idx="2">
+            <a:schemeClr val="accent1"/>
+          </a:lnRef>
+          <a:fillRef idx="0">
+            <a:schemeClr val="accent1"/>
+          </a:fillRef>
+          <a:effectRef idx="1">
+            <a:schemeClr val="accent1"/>
+          </a:effectRef>
+          <a:fontRef idx="minor">
+            <a:schemeClr val="tx1"/>
+          </a:fontRef>
+        </p:style>
+      </p:cxnSp>
+      <p:sp>
+        <p:nvSpPr>
+          <p:cNvPr id="6" name="Rounded Rectangle 5"/>
+          <p:cNvSpPr/>
+          <p:nvPr/>
+        </p:nvSpPr>
+        <p:spPr>
+          <a:xfrm>
+            <a:off x="640080" y="1783080"/>
+            <a:ext cx="2331720" cy="1234440"/>
+          </a:xfrm>
+          <a:prstGeom prst="roundRect">
+            <a:avLst>
+              <a:gd name="adj" fmla="val 10000"/>
+            </a:avLst>
+          </a:prstGeom>
+          <a:solidFill>
+            <a:srgbClr val="121A2C"/>
+          </a:solidFill>
+          <a:ln w="9525">
+            <a:solidFill>
+              <a:srgbClr val="223055"/>
+            </a:solidFill>
+          </a:ln>
+          <a:effectLst/>
+        </p:spPr>
+        <p:style>
+          <a:lnRef idx="1">
+            <a:schemeClr val="accent1"/>
+          </a:lnRef>
+          <a:fillRef idx="3">
+            <a:schemeClr val="accent1"/>
+          </a:fillRef>
+          <a:effectRef idx="2">
+            <a:schemeClr val="accent1"/>
+          </a:effectRef>
+          <a:fontRef idx="minor">
+            <a:schemeClr val="lt1"/>
+          </a:fontRef>
+        </p:style>
+        <p:txBody>
+          <a:bodyPr rtlCol="0" anchor="ctr"/>
+          <a:lstStyle/>
+          <a:p>
+            <a:pPr algn="ctr"/>
+          </a:p>
+        </p:txBody>
+      </p:sp>
+      <p:sp>
+        <p:nvSpPr>
+          <p:cNvPr id="7" name="TextBox 6"/>
+          <p:cNvSpPr txBox="1"/>
+          <p:nvPr/>
+        </p:nvSpPr>
+        <p:spPr>
+          <a:xfrm>
+            <a:off x="804672" y="1938528"/>
+            <a:ext cx="2002536" cy="502920"/>
+          </a:xfrm>
+          <a:prstGeom prst="rect">
+            <a:avLst/>
+          </a:prstGeom>
+          <a:noFill/>
+        </p:spPr>
+        <p:txBody>
+          <a:bodyPr wrap="square" anchor="t" lIns="0" rIns="0" tIns="0" bIns="0">
+            <a:spAutoFit/>
+          </a:bodyPr>
+          <a:lstStyle/>
+          <a:p>
+            <a:pPr algn="l">
+              <a:lnSpc>
+                <a:spcPct val="100000"/>
+              </a:lnSpc>
+            </a:pPr>
+            <a:r>
+              <a:rPr sz="2100" b="1" i="0">
+                <a:solidFill>
+                  <a:srgbClr val="DD9A34"/>
+                </a:solidFill>
+                <a:latin typeface="Arial"/>
+              </a:rPr>
+              <a:t>24.000.000</a:t>
+            </a:r>
+          </a:p>
+        </p:txBody>
+      </p:sp>
+      <p:sp>
+        <p:nvSpPr>
+          <p:cNvPr id="8" name="TextBox 7"/>
+          <p:cNvSpPr txBox="1"/>
+          <p:nvPr/>
+        </p:nvSpPr>
+        <p:spPr>
+          <a:xfrm>
+            <a:off x="804672" y="2487168"/>
+            <a:ext cx="2002536" cy="457200"/>
+          </a:xfrm>
+          <a:prstGeom prst="rect">
+            <a:avLst/>
+          </a:prstGeom>
+          <a:noFill/>
+        </p:spPr>
+        <p:txBody>
+          <a:bodyPr wrap="square" anchor="t" lIns="0" rIns="0" tIns="0" bIns="0">
+            <a:spAutoFit/>
+          </a:bodyPr>
+          <a:lstStyle/>
+          <a:p>
+            <a:pPr algn="l">
+              <a:lnSpc>
+                <a:spcPct val="120000"/>
+              </a:lnSpc>
+            </a:pPr>
+            <a:r>
+              <a:rPr sz="950" b="0" i="0">
+                <a:solidFill>
+                  <a:srgbClr val="9FB6DD"/>
+                </a:solidFill>
+                <a:latin typeface="Arial"/>
+              </a:rPr>
+              <a:t>PMEs no Brasil (TAM, SEBRAE 2025)</a:t>
+            </a:r>
+          </a:p>
+        </p:txBody>
+      </p:sp>
+      <p:sp>
+        <p:nvSpPr>
+          <p:cNvPr id="9" name="Rounded Rectangle 8"/>
+          <p:cNvSpPr/>
+          <p:nvPr/>
+        </p:nvSpPr>
+        <p:spPr>
+          <a:xfrm>
+            <a:off x="3291840" y="1783080"/>
+            <a:ext cx="2331720" cy="1234440"/>
+          </a:xfrm>
+          <a:prstGeom prst="roundRect">
+            <a:avLst>
+              <a:gd name="adj" fmla="val 10000"/>
+            </a:avLst>
+          </a:prstGeom>
+          <a:solidFill>
+            <a:srgbClr val="121A2C"/>
+          </a:solidFill>
+          <a:ln w="9525">
+            <a:solidFill>
+              <a:srgbClr val="223055"/>
+            </a:solidFill>
+          </a:ln>
+          <a:effectLst/>
+        </p:spPr>
+        <p:style>
+          <a:lnRef idx="1">
+            <a:schemeClr val="accent1"/>
+          </a:lnRef>
+          <a:fillRef idx="3">
+            <a:schemeClr val="accent1"/>
+          </a:fillRef>
+          <a:effectRef idx="2">
+            <a:schemeClr val="accent1"/>
+          </a:effectRef>
+          <a:fontRef idx="minor">
+            <a:schemeClr val="lt1"/>
+          </a:fontRef>
+        </p:style>
+        <p:txBody>
+          <a:bodyPr rtlCol="0" anchor="ctr"/>
+          <a:lstStyle/>
+          <a:p>
+            <a:pPr algn="ctr"/>
+          </a:p>
+        </p:txBody>
+      </p:sp>
+      <p:sp>
+        <p:nvSpPr>
+          <p:cNvPr id="10" name="TextBox 9"/>
+          <p:cNvSpPr txBox="1"/>
+          <p:nvPr/>
+        </p:nvSpPr>
+        <p:spPr>
+          <a:xfrm>
+            <a:off x="3456432" y="1938528"/>
+            <a:ext cx="2002536" cy="502920"/>
+          </a:xfrm>
+          <a:prstGeom prst="rect">
+            <a:avLst/>
+          </a:prstGeom>
+          <a:noFill/>
+        </p:spPr>
+        <p:txBody>
+          <a:bodyPr wrap="square" anchor="t" lIns="0" rIns="0" tIns="0" bIns="0">
+            <a:spAutoFit/>
+          </a:bodyPr>
+          <a:lstStyle/>
+          <a:p>
+            <a:pPr algn="l">
+              <a:lnSpc>
+                <a:spcPct val="100000"/>
+              </a:lnSpc>
+            </a:pPr>
+            <a:r>
+              <a:rPr sz="2100" b="1" i="0">
+                <a:solidFill>
+                  <a:srgbClr val="DD9A34"/>
+                </a:solidFill>
+                <a:latin typeface="Arial"/>
+              </a:rPr>
+              <a:t>× 0,1%</a:t>
+            </a:r>
+          </a:p>
+        </p:txBody>
+      </p:sp>
+      <p:sp>
+        <p:nvSpPr>
+          <p:cNvPr id="11" name="TextBox 10"/>
+          <p:cNvSpPr txBox="1"/>
+          <p:nvPr/>
+        </p:nvSpPr>
+        <p:spPr>
+          <a:xfrm>
+            <a:off x="3456432" y="2487168"/>
+            <a:ext cx="2002536" cy="457200"/>
+          </a:xfrm>
+          <a:prstGeom prst="rect">
+            <a:avLst/>
+          </a:prstGeom>
+          <a:noFill/>
+        </p:spPr>
+        <p:txBody>
+          <a:bodyPr wrap="square" anchor="t" lIns="0" rIns="0" tIns="0" bIns="0">
+            <a:spAutoFit/>
+          </a:bodyPr>
+          <a:lstStyle/>
+          <a:p>
+            <a:pPr algn="l">
+              <a:lnSpc>
+                <a:spcPct val="120000"/>
+              </a:lnSpc>
+            </a:pPr>
+            <a:r>
+              <a:rPr sz="950" b="0" i="0">
+                <a:solidFill>
+                  <a:srgbClr val="9FB6DD"/>
+                </a:solidFill>
+                <a:latin typeface="Arial"/>
+              </a:rPr>
+              <a:t>Meta de participação de mercado</a:t>
+            </a:r>
+          </a:p>
+        </p:txBody>
+      </p:sp>
+      <p:sp>
+        <p:nvSpPr>
+          <p:cNvPr id="12" name="Rounded Rectangle 11"/>
+          <p:cNvSpPr/>
+          <p:nvPr/>
+        </p:nvSpPr>
+        <p:spPr>
+          <a:xfrm>
+            <a:off x="5943600" y="1783080"/>
+            <a:ext cx="2331720" cy="1234440"/>
+          </a:xfrm>
+          <a:prstGeom prst="roundRect">
+            <a:avLst>
+              <a:gd name="adj" fmla="val 10000"/>
+            </a:avLst>
+          </a:prstGeom>
+          <a:solidFill>
+            <a:srgbClr val="121A2C"/>
+          </a:solidFill>
+          <a:ln w="9525">
+            <a:solidFill>
+              <a:srgbClr val="223055"/>
+            </a:solidFill>
+          </a:ln>
+          <a:effectLst/>
+        </p:spPr>
+        <p:style>
+          <a:lnRef idx="1">
+            <a:schemeClr val="accent1"/>
+          </a:lnRef>
+          <a:fillRef idx="3">
+            <a:schemeClr val="accent1"/>
+          </a:fillRef>
+          <a:effectRef idx="2">
+            <a:schemeClr val="accent1"/>
+          </a:effectRef>
+          <a:fontRef idx="minor">
+            <a:schemeClr val="lt1"/>
+          </a:fontRef>
+        </p:style>
+        <p:txBody>
+          <a:bodyPr rtlCol="0" anchor="ctr"/>
+          <a:lstStyle/>
+          <a:p>
+            <a:pPr algn="ctr"/>
+          </a:p>
+        </p:txBody>
+      </p:sp>
+      <p:sp>
+        <p:nvSpPr>
+          <p:cNvPr id="13" name="TextBox 12"/>
+          <p:cNvSpPr txBox="1"/>
+          <p:nvPr/>
+        </p:nvSpPr>
+        <p:spPr>
+          <a:xfrm>
+            <a:off x="6108192" y="1938528"/>
+            <a:ext cx="2002536" cy="502920"/>
+          </a:xfrm>
+          <a:prstGeom prst="rect">
+            <a:avLst/>
+          </a:prstGeom>
+          <a:noFill/>
+        </p:spPr>
+        <p:txBody>
+          <a:bodyPr wrap="square" anchor="t" lIns="0" rIns="0" tIns="0" bIns="0">
+            <a:spAutoFit/>
+          </a:bodyPr>
+          <a:lstStyle/>
+          <a:p>
+            <a:pPr algn="l">
+              <a:lnSpc>
+                <a:spcPct val="100000"/>
+              </a:lnSpc>
+            </a:pPr>
+            <a:r>
+              <a:rPr sz="2100" b="1" i="0">
+                <a:solidFill>
+                  <a:srgbClr val="DD9A34"/>
+                </a:solidFill>
+                <a:latin typeface="Arial"/>
+              </a:rPr>
+              <a:t>= 24.000</a:t>
+            </a:r>
+          </a:p>
+        </p:txBody>
+      </p:sp>
+      <p:sp>
+        <p:nvSpPr>
+          <p:cNvPr id="14" name="TextBox 13"/>
+          <p:cNvSpPr txBox="1"/>
+          <p:nvPr/>
+        </p:nvSpPr>
+        <p:spPr>
+          <a:xfrm>
+            <a:off x="6108192" y="2487168"/>
+            <a:ext cx="2002536" cy="457200"/>
+          </a:xfrm>
+          <a:prstGeom prst="rect">
+            <a:avLst/>
+          </a:prstGeom>
+          <a:noFill/>
+        </p:spPr>
+        <p:txBody>
+          <a:bodyPr wrap="square" anchor="t" lIns="0" rIns="0" tIns="0" bIns="0">
+            <a:spAutoFit/>
+          </a:bodyPr>
+          <a:lstStyle/>
+          <a:p>
+            <a:pPr algn="l">
+              <a:lnSpc>
+                <a:spcPct val="120000"/>
+              </a:lnSpc>
+            </a:pPr>
+            <a:r>
+              <a:rPr sz="950" b="0" i="0">
+                <a:solidFill>
+                  <a:srgbClr val="9FB6DD"/>
+                </a:solidFill>
+                <a:latin typeface="Arial"/>
+              </a:rPr>
+              <a:t>Clientes-alvo</a:t>
+            </a:r>
+          </a:p>
+        </p:txBody>
+      </p:sp>
+      <p:sp>
+        <p:nvSpPr>
+          <p:cNvPr id="15" name="TextBox 14"/>
+          <p:cNvSpPr txBox="1"/>
+          <p:nvPr/>
+        </p:nvSpPr>
+        <p:spPr>
+          <a:xfrm>
+            <a:off x="640080" y="3246120"/>
+            <a:ext cx="10515600" cy="320040"/>
+          </a:xfrm>
+          <a:prstGeom prst="rect">
+            <a:avLst/>
+          </a:prstGeom>
+          <a:noFill/>
+        </p:spPr>
+        <p:txBody>
+          <a:bodyPr wrap="square" anchor="t" lIns="0" rIns="0" tIns="0" bIns="0">
+            <a:spAutoFit/>
+          </a:bodyPr>
+          <a:lstStyle/>
+          <a:p>
+            <a:pPr algn="l">
+              <a:lnSpc>
+                <a:spcPct val="100000"/>
+              </a:lnSpc>
+            </a:pPr>
+            <a:r>
+              <a:rPr sz="1500" b="0" i="0">
+                <a:solidFill>
+                  <a:srgbClr val="CFD8EC"/>
+                </a:solidFill>
+                <a:latin typeface="Arial"/>
+              </a:rPr>
+              <a:t>24.000 clientes  ×  R$ 3.500/mês  ×  12 meses de contrato</a:t>
+            </a:r>
+          </a:p>
+        </p:txBody>
+      </p:sp>
+      <p:sp>
+        <p:nvSpPr>
+          <p:cNvPr id="16" name="Rounded Rectangle 15"/>
+          <p:cNvSpPr/>
+          <p:nvPr/>
+        </p:nvSpPr>
+        <p:spPr>
+          <a:xfrm>
+            <a:off x="640080" y="3703320"/>
+            <a:ext cx="6400800" cy="1737360"/>
+          </a:xfrm>
+          <a:prstGeom prst="roundRect">
+            <a:avLst>
+              <a:gd name="adj" fmla="val 8000"/>
+            </a:avLst>
+          </a:prstGeom>
+          <a:solidFill>
+            <a:srgbClr val="1C2B4A"/>
+          </a:solidFill>
+          <a:ln>
+            <a:noFill/>
+          </a:ln>
+          <a:effectLst/>
+        </p:spPr>
+        <p:style>
+          <a:lnRef idx="1">
+            <a:schemeClr val="accent1"/>
+          </a:lnRef>
+          <a:fillRef idx="3">
+            <a:schemeClr val="accent1"/>
+          </a:fillRef>
+          <a:effectRef idx="2">
+            <a:schemeClr val="accent1"/>
+          </a:effectRef>
+          <a:fontRef idx="minor">
+            <a:schemeClr val="lt1"/>
+          </a:fontRef>
+        </p:style>
+        <p:txBody>
+          <a:bodyPr rtlCol="0" anchor="ctr"/>
+          <a:lstStyle/>
+          <a:p>
+            <a:pPr algn="ctr"/>
+          </a:p>
+        </p:txBody>
+      </p:sp>
+      <p:sp>
+        <p:nvSpPr>
+          <p:cNvPr id="17" name="TextBox 16"/>
+          <p:cNvSpPr txBox="1"/>
+          <p:nvPr/>
+        </p:nvSpPr>
+        <p:spPr>
+          <a:xfrm>
+            <a:off x="914400" y="3886200"/>
+            <a:ext cx="5852160" cy="320040"/>
+          </a:xfrm>
+          <a:prstGeom prst="rect">
+            <a:avLst/>
+          </a:prstGeom>
+          <a:noFill/>
+        </p:spPr>
+        <p:txBody>
+          <a:bodyPr wrap="square" anchor="t" lIns="0" rIns="0" tIns="0" bIns="0">
+            <a:spAutoFit/>
+          </a:bodyPr>
+          <a:lstStyle/>
+          <a:p>
+            <a:pPr algn="l">
+              <a:lnSpc>
+                <a:spcPct val="100000"/>
+              </a:lnSpc>
+            </a:pPr>
+            <a:r>
+              <a:rPr sz="1050" b="1" i="0">
+                <a:solidFill>
+                  <a:srgbClr val="9FB6DD"/>
+                </a:solidFill>
+                <a:latin typeface="Arial"/>
+              </a:rPr>
+              <a:t>RECEITA ANUAL PROJETADA (MENSALIDADE)</a:t>
+            </a:r>
+          </a:p>
+        </p:txBody>
+      </p:sp>
+      <p:sp>
+        <p:nvSpPr>
+          <p:cNvPr id="18" name="TextBox 17"/>
+          <p:cNvSpPr txBox="1"/>
+          <p:nvPr/>
+        </p:nvSpPr>
+        <p:spPr>
+          <a:xfrm>
+            <a:off x="914400" y="4206240"/>
+            <a:ext cx="5852160" cy="1005840"/>
+          </a:xfrm>
+          <a:prstGeom prst="rect">
+            <a:avLst/>
+          </a:prstGeom>
+          <a:noFill/>
+        </p:spPr>
+        <p:txBody>
+          <a:bodyPr wrap="square" anchor="t" lIns="0" rIns="0" tIns="0" bIns="0">
+            <a:spAutoFit/>
+          </a:bodyPr>
+          <a:lstStyle/>
+          <a:p>
+            <a:pPr algn="l">
+              <a:lnSpc>
+                <a:spcPct val="100000"/>
+              </a:lnSpc>
+            </a:pPr>
+            <a:r>
+              <a:rPr sz="4000" b="1" i="0">
+                <a:solidFill>
+                  <a:srgbClr val="DD9A34"/>
+                </a:solidFill>
+                <a:latin typeface="Arial"/>
+              </a:rPr>
+              <a:t>R$ 1.008.000.000</a:t>
+            </a:r>
+          </a:p>
+        </p:txBody>
+      </p:sp>
+      <p:sp>
+        <p:nvSpPr>
+          <p:cNvPr id="19" name="Rounded Rectangle 18"/>
+          <p:cNvSpPr/>
+          <p:nvPr/>
+        </p:nvSpPr>
+        <p:spPr>
+          <a:xfrm>
+            <a:off x="7223760" y="3703320"/>
+            <a:ext cx="4297680" cy="1737360"/>
+          </a:xfrm>
+          <a:prstGeom prst="roundRect">
+            <a:avLst>
+              <a:gd name="adj" fmla="val 8000"/>
+            </a:avLst>
+          </a:prstGeom>
+          <a:solidFill>
+            <a:srgbClr val="121A2C"/>
+          </a:solidFill>
+          <a:ln w="9525">
+            <a:solidFill>
+              <a:srgbClr val="223055"/>
+            </a:solidFill>
+          </a:ln>
+          <a:effectLst/>
+        </p:spPr>
+        <p:style>
+          <a:lnRef idx="1">
+            <a:schemeClr val="accent1"/>
+          </a:lnRef>
+          <a:fillRef idx="3">
+            <a:schemeClr val="accent1"/>
+          </a:fillRef>
+          <a:effectRef idx="2">
+            <a:schemeClr val="accent1"/>
+          </a:effectRef>
+          <a:fontRef idx="minor">
+            <a:schemeClr val="lt1"/>
+          </a:fontRef>
+        </p:style>
+        <p:txBody>
+          <a:bodyPr rtlCol="0" anchor="ctr"/>
+          <a:lstStyle/>
+          <a:p>
+            <a:pPr algn="ctr"/>
+          </a:p>
+        </p:txBody>
+      </p:sp>
+      <p:sp>
+        <p:nvSpPr>
+          <p:cNvPr id="20" name="TextBox 19"/>
+          <p:cNvSpPr txBox="1"/>
+          <p:nvPr/>
+        </p:nvSpPr>
+        <p:spPr>
+          <a:xfrm>
+            <a:off x="7452360" y="3886200"/>
+            <a:ext cx="3840480" cy="320040"/>
+          </a:xfrm>
+          <a:prstGeom prst="rect">
+            <a:avLst/>
+          </a:prstGeom>
+          <a:noFill/>
+        </p:spPr>
+        <p:txBody>
+          <a:bodyPr wrap="square" anchor="t" lIns="0" rIns="0" tIns="0" bIns="0">
+            <a:spAutoFit/>
+          </a:bodyPr>
+          <a:lstStyle/>
+          <a:p>
+            <a:pPr algn="l">
+              <a:lnSpc>
+                <a:spcPct val="100000"/>
+              </a:lnSpc>
+            </a:pPr>
+            <a:r>
+              <a:rPr sz="950" b="1" i="0">
+                <a:solidFill>
+                  <a:srgbClr val="9FB6DD"/>
+                </a:solidFill>
+                <a:latin typeface="Arial"/>
+              </a:rPr>
+              <a:t>SETUP, SE OS 24.000 FOSSEM NOVOS NO ANO</a:t>
+            </a:r>
+          </a:p>
+        </p:txBody>
+      </p:sp>
+      <p:sp>
+        <p:nvSpPr>
+          <p:cNvPr id="21" name="TextBox 20"/>
+          <p:cNvSpPr txBox="1"/>
+          <p:nvPr/>
+        </p:nvSpPr>
+        <p:spPr>
+          <a:xfrm>
+            <a:off x="7452360" y="4224528"/>
+            <a:ext cx="3840480" cy="640080"/>
+          </a:xfrm>
+          <a:prstGeom prst="rect">
+            <a:avLst/>
+          </a:prstGeom>
+          <a:noFill/>
+        </p:spPr>
+        <p:txBody>
+          <a:bodyPr wrap="square" anchor="t" lIns="0" rIns="0" tIns="0" bIns="0">
+            <a:spAutoFit/>
+          </a:bodyPr>
+          <a:lstStyle/>
+          <a:p>
+            <a:pPr algn="l">
+              <a:lnSpc>
+                <a:spcPct val="100000"/>
+              </a:lnSpc>
+            </a:pPr>
+            <a:r>
+              <a:rPr sz="2200" b="1" i="0">
+                <a:solidFill>
+                  <a:srgbClr val="FFFFFF"/>
+                </a:solidFill>
+                <a:latin typeface="Arial"/>
+              </a:rPr>
+              <a:t>R$ 300.000.000</a:t>
+            </a:r>
+          </a:p>
+        </p:txBody>
+      </p:sp>
+      <p:sp>
+        <p:nvSpPr>
+          <p:cNvPr id="22" name="TextBox 21"/>
+          <p:cNvSpPr txBox="1"/>
+          <p:nvPr/>
+        </p:nvSpPr>
+        <p:spPr>
+          <a:xfrm>
+            <a:off x="7452360" y="4828032"/>
+            <a:ext cx="3840480" cy="548640"/>
+          </a:xfrm>
+          <a:prstGeom prst="rect">
+            <a:avLst/>
+          </a:prstGeom>
+          <a:noFill/>
+        </p:spPr>
+        <p:txBody>
+          <a:bodyPr wrap="square" anchor="t" lIns="0" rIns="0" tIns="0" bIns="0">
+            <a:spAutoFit/>
+          </a:bodyPr>
+          <a:lstStyle/>
+          <a:p>
+            <a:pPr algn="l">
+              <a:lnSpc>
+                <a:spcPct val="120000"/>
+              </a:lnSpc>
+            </a:pPr>
+            <a:r>
+              <a:rPr sz="900" b="0" i="1">
+                <a:solidFill>
+                  <a:srgbClr val="8A93A8"/>
+                </a:solidFill>
+                <a:latin typeface="Arial"/>
+              </a:rPr>
+              <a:t>24.000 × R$ 12.500 (hipotético — ilustra o teto, não uma premissa de ritmo de vendas)</a:t>
+            </a:r>
+          </a:p>
+        </p:txBody>
+      </p:sp>
+      <p:sp>
+        <p:nvSpPr>
+          <p:cNvPr id="23" name="Rounded Rectangle 22"/>
+          <p:cNvSpPr/>
+          <p:nvPr/>
+        </p:nvSpPr>
+        <p:spPr>
+          <a:xfrm>
+            <a:off x="640080" y="5623560"/>
+            <a:ext cx="10881360" cy="777240"/>
+          </a:xfrm>
+          <a:prstGeom prst="roundRect">
+            <a:avLst>
+              <a:gd name="adj" fmla="val 10000"/>
+            </a:avLst>
+          </a:prstGeom>
+          <a:solidFill>
+            <a:srgbClr val="2A2414"/>
+          </a:solidFill>
+          <a:ln>
+            <a:noFill/>
+          </a:ln>
+          <a:effectLst/>
+        </p:spPr>
+        <p:style>
+          <a:lnRef idx="1">
+            <a:schemeClr val="accent1"/>
+          </a:lnRef>
+          <a:fillRef idx="3">
+            <a:schemeClr val="accent1"/>
+          </a:fillRef>
+          <a:effectRef idx="2">
+            <a:schemeClr val="accent1"/>
+          </a:effectRef>
+          <a:fontRef idx="minor">
+            <a:schemeClr val="lt1"/>
+          </a:fontRef>
+        </p:style>
+        <p:txBody>
+          <a:bodyPr rtlCol="0" anchor="ctr"/>
+          <a:lstStyle/>
+          <a:p>
+            <a:pPr algn="ctr"/>
+          </a:p>
+        </p:txBody>
+      </p:sp>
+      <p:sp>
+        <p:nvSpPr>
+          <p:cNvPr id="24" name="TextBox 23"/>
+          <p:cNvSpPr txBox="1"/>
+          <p:nvPr/>
+        </p:nvSpPr>
+        <p:spPr>
+          <a:xfrm>
+            <a:off x="914400" y="5779008"/>
+            <a:ext cx="10332720" cy="502920"/>
+          </a:xfrm>
+          <a:prstGeom prst="rect">
+            <a:avLst/>
+          </a:prstGeom>
+          <a:noFill/>
+        </p:spPr>
+        <p:txBody>
+          <a:bodyPr wrap="square" anchor="ctr" lIns="0" rIns="0" tIns="0" bIns="0">
+            <a:spAutoFit/>
+          </a:bodyPr>
+          <a:lstStyle/>
+          <a:p>
+            <a:pPr algn="l">
+              <a:lnSpc>
+                <a:spcPct val="120000"/>
+              </a:lnSpc>
+            </a:pPr>
+            <a:r>
+              <a:rPr sz="1100" b="0" i="1">
+                <a:solidFill>
+                  <a:srgbClr val="E8C98A"/>
+                </a:solidFill>
+                <a:latin typeface="Arial"/>
+              </a:rPr>
+              <a:t>⚠  Meta, não fato — 0,1% de participação é alvo do Grupo Sena, não projeção validada por funil comercial real. Mesma disciplina do Anexo de Premissas do business plan geral.</a:t>
+            </a:r>
+          </a:p>
+        </p:txBody>
+      </p:sp>
+      <p:cxnSp>
+        <p:nvCxnSpPr>
+          <p:cNvPr id="25" name="Connector 24"/>
+          <p:cNvCxnSpPr/>
+          <p:nvPr/>
+        </p:nvCxnSpPr>
+        <p:spPr>
+          <a:xfrm>
+            <a:off x="502920" y="6355080"/>
+            <a:ext cx="11185855" cy="0"/>
+          </a:xfrm>
+          <a:prstGeom prst="line">
+            <a:avLst/>
+          </a:prstGeom>
+          <a:ln w="9525">
+            <a:solidFill>
+              <a:srgbClr val="7C8AA8"/>
+            </a:solidFill>
+          </a:ln>
+        </p:spPr>
+        <p:style>
+          <a:lnRef idx="2">
+            <a:schemeClr val="accent1"/>
+          </a:lnRef>
+          <a:fillRef idx="0">
+            <a:schemeClr val="accent1"/>
+          </a:fillRef>
+          <a:effectRef idx="1">
+            <a:schemeClr val="accent1"/>
+          </a:effectRef>
+          <a:fontRef idx="minor">
+            <a:schemeClr val="tx1"/>
+          </a:fontRef>
+        </p:style>
+      </p:cxnSp>
+      <p:sp>
+        <p:nvSpPr>
+          <p:cNvPr id="26" name="TextBox 25"/>
+          <p:cNvSpPr txBox="1"/>
+          <p:nvPr/>
+        </p:nvSpPr>
+        <p:spPr>
+          <a:xfrm>
+            <a:off x="502920" y="6419088"/>
+            <a:ext cx="3657600" cy="274320"/>
+          </a:xfrm>
+          <a:prstGeom prst="rect">
+            <a:avLst/>
+          </a:prstGeom>
+          <a:noFill/>
+        </p:spPr>
+        <p:txBody>
+          <a:bodyPr wrap="square" anchor="t" lIns="0" rIns="0" tIns="0" bIns="0">
+            <a:spAutoFit/>
+          </a:bodyPr>
+          <a:lstStyle/>
+          <a:p>
+            <a:pPr algn="l">
+              <a:lnSpc>
+                <a:spcPct val="100000"/>
+              </a:lnSpc>
+            </a:pPr>
+            <a:r>
+              <a:rPr sz="900" b="0" i="0">
+                <a:solidFill>
+                  <a:srgbClr val="7C8AA8"/>
+                </a:solidFill>
+                <a:latin typeface="Arial"/>
+              </a:rPr>
+              <a:t>OCEO · Os 5 Pilares</a:t>
+            </a:r>
+          </a:p>
+        </p:txBody>
+      </p:sp>
+      <p:sp>
+        <p:nvSpPr>
+          <p:cNvPr id="27" name="TextBox 26"/>
+          <p:cNvSpPr txBox="1"/>
+          <p:nvPr/>
+        </p:nvSpPr>
+        <p:spPr>
+          <a:xfrm>
+            <a:off x="11185855" y="6419088"/>
+            <a:ext cx="548640" cy="274320"/>
+          </a:xfrm>
+          <a:prstGeom prst="rect">
+            <a:avLst/>
+          </a:prstGeom>
+          <a:noFill/>
+        </p:spPr>
+        <p:txBody>
+          <a:bodyPr wrap="square" anchor="t" lIns="0" rIns="0" tIns="0" bIns="0">
+            <a:spAutoFit/>
+          </a:bodyPr>
+          <a:lstStyle/>
+          <a:p>
+            <a:pPr algn="r">
+              <a:lnSpc>
+                <a:spcPct val="100000"/>
+              </a:lnSpc>
+            </a:pPr>
+            <a:r>
+              <a:rPr sz="900" b="0" i="0">
+                <a:solidFill>
+                  <a:srgbClr val="7C8AA8"/>
+                </a:solidFill>
+                <a:latin typeface="Arial"/>
+              </a:rPr>
+              <a:t>13</a:t>
+            </a:r>
+          </a:p>
+        </p:txBody>
+      </p:sp>
+    </p:spTree>
+  </p:cSld>
+  <p:clrMapOvr>
+    <a:masterClrMapping/>
+  </p:clrMapOvr>
+</p:sld>
+</file>
+
+<file path=ppt/slides/slide14.xml><?xml version="1.0" encoding="utf-8"?>
+<p:sld xmlns:a="http://schemas.openxmlformats.org/drawingml/2006/main" xmlns:p="http://schemas.openxmlformats.org/presentationml/2006/main" xmlns:r="http://schemas.openxmlformats.org/officeDocument/2006/relationships">
+  <p:cSld>
+    <p:bg>
+      <p:bgPr>
+        <a:solidFill>
           <a:srgbClr val="F5F7FB"/>
         </a:solidFill>
         <a:effectLst/>
@@ -7817,7 +8896,7 @@
                 </a:solidFill>
                 <a:latin typeface="Arial"/>
               </a:rPr>
-              <a:t>05 · GOVERNANÇA DO PRODUTO</a:t>
+              <a:t>06 · GOVERNANÇA DO PRODUTO</a:t>
             </a:r>
           </a:p>
         </p:txBody>
@@ -8682,7 +9761,7 @@
                 </a:solidFill>
                 <a:latin typeface="Arial"/>
               </a:rPr>
-              <a:t>13</a:t>
+              <a:t>14</a:t>
             </a:r>
           </a:p>
         </p:txBody>
@@ -8695,7 +9774,7 @@
 </p:sld>
 </file>
 
-<file path=ppt/slides/slide14.xml><?xml version="1.0" encoding="utf-8"?>
+<file path=ppt/slides/slide15.xml><?xml version="1.0" encoding="utf-8"?>
 <p:sld xmlns:a="http://schemas.openxmlformats.org/drawingml/2006/main" xmlns:p="http://schemas.openxmlformats.org/presentationml/2006/main" xmlns:r="http://schemas.openxmlformats.org/officeDocument/2006/relationships">
   <p:cSld>
     <p:bg>
@@ -8782,7 +9861,7 @@
                 </a:solidFill>
                 <a:latin typeface="Arial"/>
               </a:rPr>
-              <a:t>06 · PRÓXIMOS PASSOS</a:t>
+              <a:t>07 · PRÓXIMOS PASSOS</a:t>
             </a:r>
           </a:p>
         </p:txBody>
@@ -9599,7 +10678,7 @@
                 </a:solidFill>
                 <a:latin typeface="Arial"/>
               </a:rPr>
-              <a:t>14</a:t>
+              <a:t>15</a:t>
             </a:r>
           </a:p>
         </p:txBody>
@@ -9612,7 +10691,7 @@
 </p:sld>
 </file>
 
-<file path=ppt/slides/slide15.xml><?xml version="1.0" encoding="utf-8"?>
+<file path=ppt/slides/slide16.xml><?xml version="1.0" encoding="utf-8"?>
 <p:sld xmlns:a="http://schemas.openxmlformats.org/drawingml/2006/main" xmlns:p="http://schemas.openxmlformats.org/presentationml/2006/main" xmlns:r="http://schemas.openxmlformats.org/officeDocument/2006/relationships">
   <p:cSld>
     <p:bg>
@@ -10708,7 +11787,7 @@
                 </a:solidFill>
                 <a:latin typeface="Arial"/>
               </a:rPr>
-              <a:t>Atualizado em 05/ago/2026 (de R$ 2.500 para R$ 3.500), cobrindo os 5 pilares. Mensalidade fixa + repasse de custo variável já identificado (ex.: conversas WhatsApp Business API acima da franquia grátis, Pilar GM).</a:t>
+              <a:t>Cobre os 5 pilares (GC, GF, GJ, GM, GI). Mensalidade fixa + repasse de custo variável já identificado (ex.: conversas WhatsApp Business API acima da franquia grátis, Pilar GM).</a:t>
             </a:r>
           </a:p>
         </p:txBody>

</xml_diff>